<commit_message>
Replace normality schematic with real per-metric figure (ResNet-18 layer4)
Adds the paired baseline/masked per-image metrics and a generator
(make_normality_fig.py) that forms d = masked - baseline and runs Shapiro-Wilk
per metric, reproducing Appendix C (Table C.2, layer4): p(MSE) < 0.001,
p(PSNR) = 0.98, p(SSIM) = 0.80. Produces a standalone titled figure and a
compact slide variant, and wires the compact one into methods deck slide 4,
replacing the synthetic schematic.
</commit_message>
<xml_diff>
--- a/slides/methods.pptx
+++ b/slides/methods.pptx
@@ -4941,7 +4941,7 @@
       </p:sp>
       <p:pic>
         <p:nvPicPr>
-          <p:cNvPr id="7" name="Picture 6" descr="normality_schematic.png"/>
+          <p:cNvPr id="7" name="Picture 6" descr="normality_per_metric_slide.png"/>
           <p:cNvPicPr>
             <a:picLocks noChangeAspect="1"/>
           </p:cNvPicPr>
@@ -4955,8 +4955,8 @@
         </p:blipFill>
         <p:spPr>
           <a:xfrm>
-            <a:off x="6172200" y="2404247"/>
-            <a:ext cx="5669280" cy="2323825"/>
+            <a:off x="6172200" y="2805593"/>
+            <a:ext cx="5669280" cy="1612574"/>
           </a:xfrm>
           <a:prstGeom prst="rect">
             <a:avLst/>
@@ -4971,7 +4971,7 @@
         </p:nvSpPr>
         <p:spPr>
           <a:xfrm>
-            <a:off x="6172200" y="5074920"/>
+            <a:off x="6172200" y="4983480"/>
             <a:ext cx="5669280" cy="457200"/>
           </a:xfrm>
           <a:prstGeom prst="rect">
@@ -5003,7 +5003,7 @@
                 </a:solidFill>
                 <a:latin typeface="Calibri"/>
               </a:rPr>
-              <a:t>Schematic — illustrates the distribution-shape argument, not measured data.</a:t>
+              <a:t>Real data: ResNet-18, mask = layer4, n = 30. Per-image differences (masked − baseline); reproduces Appendix C.</a:t>
             </a:r>
           </a:p>
         </p:txBody>

</xml_diff>